<commit_message>
docs: revisao v1.1 - remove veiculos/motoristas e adota agenda por horario
Ajustes solicitados pela Secretaria de Saude:
- Remove os cadastros de Veiculos e Motoristas (modulos e entidades)
- Agenda organizada por horario (06:00-16:30, seg-sex), em ordem de
  agendamento; substitui o antigo Mapa de Viagem pela Lista do Dia
- Relatorios com consultas por agendamento, dia, mes, nome e outros
- Atualiza MER, perfis (remove Motorista), fases e decisoes pendentes
- Atualiza a apresentacao institucional para refletir os mesmos ajustes

Co-Authored-By: Claude Opus 4.8 <noreply@anthropic.com>
Claude-Session: https://claude.ai/code/session_01RwkWeeZuQzAXsxBUaQxZem
</commit_message>
<xml_diff>
--- a/docs/SIGTRANS_Saude_Apresentacao.pptx
+++ b/docs/SIGTRANS_Saude_Apresentacao.pptx
@@ -863,7 +863,7 @@
           <a:p>
             <a:r>
               <a:rPr lang="en-US" dirty="0"/>
-              <a:t>Fluxo alvo: Senha, Cadastro, Agendamento, Cartão de Embarque, Mapa de Viagem, Embarque, Relatório do BPA. Cada etapa aproveita os dados da anterior.</a:t>
+              <a:t>Fluxo alvo: Senha, Cadastro, Agendamento, Cartão de Embarque, Lista do Dia, Embarque, Relatório do BPA. Cada etapa aproveita os dados da anterior.</a:t>
             </a:r>
             <a:endParaRPr lang="en-US" dirty="0"/>
           </a:p>
@@ -951,7 +951,7 @@
           <a:p>
             <a:r>
               <a:rPr lang="en-US" dirty="0"/>
-              <a:t>Benefício concreto por perfil: atendente, coordenação, motorista e paciente. Todos ganham com a informatização.</a:t>
+              <a:t>Benefício concreto por perfil: atendente, coordenação e paciente. Todos ganham com a informatização.</a:t>
             </a:r>
             <a:endParaRPr lang="en-US" dirty="0"/>
           </a:p>
@@ -2528,7 +2528,7 @@
                 <a:ea typeface="Calibri" pitchFamily="34" charset="-122"/>
                 <a:cs typeface="Calibri" pitchFamily="34" charset="-120"/>
               </a:rPr>
-              <a:t>Fichas de marcação, planilha da van e cartão de embarque preenchidos à mão.</a:t>
+              <a:t>Fichas de marcação e cartão de embarque preenchidos à mão.</a:t>
             </a:r>
             <a:endParaRPr lang="en-US" sz="1250" dirty="0"/>
           </a:p>
@@ -2790,7 +2790,7 @@
                 <a:ea typeface="Calibri" pitchFamily="34" charset="-122"/>
                 <a:cs typeface="Calibri" pitchFamily="34" charset="-120"/>
               </a:rPr>
-              <a:t>Sem controle de lotação</a:t>
+              <a:t>Agenda no papel</a:t>
             </a:r>
             <a:endParaRPr lang="en-US" sz="1600" dirty="0"/>
           </a:p>
@@ -2832,7 +2832,7 @@
                 <a:ea typeface="Calibri" pitchFamily="34" charset="-122"/>
                 <a:cs typeface="Calibri" pitchFamily="34" charset="-120"/>
               </a:rPr>
-              <a:t>Risco de agendar mais pacientes do que a van comporta.</a:t>
+              <a:t>Horários controlados à mão, sem organização por horário.</a:t>
             </a:r>
             <a:endParaRPr lang="en-US" sz="1250" dirty="0"/>
           </a:p>
@@ -3524,7 +3524,7 @@
                 <a:ea typeface="Calibri" pitchFamily="34" charset="-122"/>
                 <a:cs typeface="Calibri" pitchFamily="34" charset="-120"/>
               </a:rPr>
-              <a:t>Preencheu uma vez, aproveita em todo lugar: cartão, mapa da van e relatórios.</a:t>
+              <a:t>Preencheu uma vez, aproveita em todo lugar: cartão, lista do dia e relatórios.</a:t>
             </a:r>
             <a:endParaRPr lang="en-US" sz="1300" dirty="0"/>
           </a:p>
@@ -3649,7 +3649,7 @@
                 <a:ea typeface="Calibri" pitchFamily="34" charset="-122"/>
                 <a:cs typeface="Calibri" pitchFamily="34" charset="-120"/>
               </a:rPr>
-              <a:t>Controle automático</a:t>
+              <a:t>Agenda organizada</a:t>
             </a:r>
             <a:endParaRPr lang="en-US" sz="1700" dirty="0"/>
           </a:p>
@@ -3691,7 +3691,7 @@
                 <a:ea typeface="Calibri" pitchFamily="34" charset="-122"/>
                 <a:cs typeface="Calibri" pitchFamily="34" charset="-120"/>
               </a:rPr>
-              <a:t>A lotação da van é controlada pelo sistema; quem excede vai para a lista de espera.</a:t>
+              <a:t>Atendimentos por horário, das 06:00 às 16:30, de segunda a sexta, em ordem.</a:t>
             </a:r>
             <a:endParaRPr lang="en-US" sz="1300" dirty="0"/>
           </a:p>
@@ -4539,7 +4539,7 @@
                 <a:ea typeface="Calibri" pitchFamily="34" charset="-122"/>
                 <a:cs typeface="Calibri" pitchFamily="34" charset="-120"/>
               </a:rPr>
-              <a:t>Veículo e vaga</a:t>
+              <a:t>Horário na agenda</a:t>
             </a:r>
             <a:endParaRPr lang="en-US" sz="1100" dirty="0"/>
           </a:p>
@@ -4826,7 +4826,7 @@
                 <a:ea typeface="Calibri" pitchFamily="34" charset="-122"/>
                 <a:cs typeface="Calibri" pitchFamily="34" charset="-120"/>
               </a:rPr>
-              <a:t>Mapa da viagem</a:t>
+              <a:t>Lista do dia</a:t>
             </a:r>
             <a:endParaRPr lang="en-US" sz="1400" dirty="0"/>
           </a:p>
@@ -4865,7 +4865,7 @@
                 <a:ea typeface="Calibri" pitchFamily="34" charset="-122"/>
                 <a:cs typeface="Calibri" pitchFamily="34" charset="-120"/>
               </a:rPr>
-              <a:t>Para o motorista</a:t>
+              <a:t>Pacientes por horário</a:t>
             </a:r>
             <a:endParaRPr lang="en-US" sz="1100" dirty="0"/>
           </a:p>
@@ -5335,12 +5335,12 @@
         </p:nvSpPr>
         <p:spPr>
           <a:xfrm>
-            <a:off x="822960" y="2011680"/>
-            <a:ext cx="5120640" cy="1874520"/>
+            <a:off x="822960" y="2194560"/>
+            <a:ext cx="3511296" cy="3063240"/>
           </a:xfrm>
           <a:prstGeom prst="roundRect">
             <a:avLst>
-              <a:gd name="adj" fmla="val 4878"/>
+              <a:gd name="adj" fmla="val 3582"/>
             </a:avLst>
           </a:prstGeom>
           <a:solidFill>
@@ -5362,8 +5362,8 @@
         </p:nvSpPr>
         <p:spPr>
           <a:xfrm>
-            <a:off x="1143000" y="2468880"/>
-            <a:ext cx="960120" cy="960120"/>
+            <a:off x="2029968" y="2606040"/>
+            <a:ext cx="1097280" cy="1097280"/>
           </a:xfrm>
           <a:prstGeom prst="ellipse">
             <a:avLst/>
@@ -5390,8 +5390,8 @@
         </p:blipFill>
         <p:spPr>
           <a:xfrm>
-            <a:off x="1389888" y="2715768"/>
-            <a:ext cx="466344" cy="466344"/>
+            <a:off x="2313432" y="2889504"/>
+            <a:ext cx="530352" cy="530352"/>
           </a:xfrm>
           <a:prstGeom prst="rect">
             <a:avLst/>
@@ -5406,8 +5406,8 @@
         </p:nvSpPr>
         <p:spPr>
           <a:xfrm>
-            <a:off x="2331720" y="2395728"/>
-            <a:ext cx="3337560" cy="457200"/>
+            <a:off x="1097280" y="3886200"/>
+            <a:ext cx="2962656" cy="457200"/>
           </a:xfrm>
           <a:prstGeom prst="rect">
             <a:avLst/>
@@ -5419,11 +5419,11 @@
           <a:bodyPr wrap="square" lIns="0" tIns="0" rIns="0" bIns="0" rtlCol="0" anchor="ctr"/>
           <a:lstStyle/>
           <a:p>
-            <a:pPr indent="0" marL="0">
-              <a:buNone/>
-            </a:pPr>
-            <a:r>
-              <a:rPr lang="en-US" sz="1800" b="1" dirty="0">
+            <a:pPr algn="ctr" indent="0" marL="0">
+              <a:buNone/>
+            </a:pPr>
+            <a:r>
+              <a:rPr lang="en-US" sz="1900" b="1" dirty="0">
                 <a:solidFill>
                   <a:srgbClr val="16323A"/>
                 </a:solidFill>
@@ -5433,7 +5433,7 @@
               </a:rPr>
               <a:t>Atendente</a:t>
             </a:r>
-            <a:endParaRPr lang="en-US" sz="1800" dirty="0"/>
+            <a:endParaRPr lang="en-US" sz="1900" dirty="0"/>
           </a:p>
         </p:txBody>
       </p:sp>
@@ -5445,8 +5445,8 @@
         </p:nvSpPr>
         <p:spPr>
           <a:xfrm>
-            <a:off x="2331720" y="2852928"/>
-            <a:ext cx="3337560" cy="914400"/>
+            <a:off x="1188720" y="4389120"/>
+            <a:ext cx="2779776" cy="777240"/>
           </a:xfrm>
           <a:prstGeom prst="rect">
             <a:avLst/>
@@ -5458,7 +5458,7 @@
           <a:bodyPr wrap="square" lIns="0" tIns="0" rIns="0" bIns="0" rtlCol="0" anchor="t"/>
           <a:lstStyle/>
           <a:p>
-            <a:pPr indent="0" marL="0">
+            <a:pPr algn="ctr" indent="0" marL="0">
               <a:lnSpc>
                 <a:spcPct val="105000"/>
               </a:lnSpc>
@@ -5473,7 +5473,7 @@
                 <a:ea typeface="Calibri" pitchFamily="34" charset="-122"/>
                 <a:cs typeface="Calibri" pitchFamily="34" charset="-120"/>
               </a:rPr>
-              <a:t>Cadastra e agenda em uma tela; emite o cartão de embarque com um clique.</a:t>
+              <a:t>Cadastra e agenda em uma só tela e emite o cartão de embarque com um clique.</a:t>
             </a:r>
             <a:endParaRPr lang="en-US" sz="1350" dirty="0"/>
           </a:p>
@@ -5487,12 +5487,12 @@
         </p:nvSpPr>
         <p:spPr>
           <a:xfrm>
-            <a:off x="6263640" y="2011680"/>
-            <a:ext cx="5120640" cy="1874520"/>
+            <a:off x="4672584" y="2194560"/>
+            <a:ext cx="3511296" cy="3063240"/>
           </a:xfrm>
           <a:prstGeom prst="roundRect">
             <a:avLst>
-              <a:gd name="adj" fmla="val 4878"/>
+              <a:gd name="adj" fmla="val 3582"/>
             </a:avLst>
           </a:prstGeom>
           <a:solidFill>
@@ -5514,8 +5514,8 @@
         </p:nvSpPr>
         <p:spPr>
           <a:xfrm>
-            <a:off x="6583680" y="2468880"/>
-            <a:ext cx="960120" cy="960120"/>
+            <a:off x="5879592" y="2606040"/>
+            <a:ext cx="1097280" cy="1097280"/>
           </a:xfrm>
           <a:prstGeom prst="ellipse">
             <a:avLst/>
@@ -5542,8 +5542,8 @@
         </p:blipFill>
         <p:spPr>
           <a:xfrm>
-            <a:off x="6830568" y="2715768"/>
-            <a:ext cx="466344" cy="466344"/>
+            <a:off x="6163056" y="2889504"/>
+            <a:ext cx="530352" cy="530352"/>
           </a:xfrm>
           <a:prstGeom prst="rect">
             <a:avLst/>
@@ -5558,8 +5558,8 @@
         </p:nvSpPr>
         <p:spPr>
           <a:xfrm>
-            <a:off x="7772400" y="2395728"/>
-            <a:ext cx="3337560" cy="457200"/>
+            <a:off x="4946904" y="3886200"/>
+            <a:ext cx="2962656" cy="457200"/>
           </a:xfrm>
           <a:prstGeom prst="rect">
             <a:avLst/>
@@ -5571,11 +5571,11 @@
           <a:bodyPr wrap="square" lIns="0" tIns="0" rIns="0" bIns="0" rtlCol="0" anchor="ctr"/>
           <a:lstStyle/>
           <a:p>
-            <a:pPr indent="0" marL="0">
-              <a:buNone/>
-            </a:pPr>
-            <a:r>
-              <a:rPr lang="en-US" sz="1800" b="1" dirty="0">
+            <a:pPr algn="ctr" indent="0" marL="0">
+              <a:buNone/>
+            </a:pPr>
+            <a:r>
+              <a:rPr lang="en-US" sz="1900" b="1" dirty="0">
                 <a:solidFill>
                   <a:srgbClr val="16323A"/>
                 </a:solidFill>
@@ -5585,7 +5585,7 @@
               </a:rPr>
               <a:t>Coordenação</a:t>
             </a:r>
-            <a:endParaRPr lang="en-US" sz="1800" dirty="0"/>
+            <a:endParaRPr lang="en-US" sz="1900" dirty="0"/>
           </a:p>
         </p:txBody>
       </p:sp>
@@ -5597,8 +5597,8 @@
         </p:nvSpPr>
         <p:spPr>
           <a:xfrm>
-            <a:off x="7772400" y="2852928"/>
-            <a:ext cx="3337560" cy="914400"/>
+            <a:off x="5038344" y="4389120"/>
+            <a:ext cx="2779776" cy="777240"/>
           </a:xfrm>
           <a:prstGeom prst="rect">
             <a:avLst/>
@@ -5610,7 +5610,7 @@
           <a:bodyPr wrap="square" lIns="0" tIns="0" rIns="0" bIns="0" rtlCol="0" anchor="t"/>
           <a:lstStyle/>
           <a:p>
-            <a:pPr indent="0" marL="0">
+            <a:pPr algn="ctr" indent="0" marL="0">
               <a:lnSpc>
                 <a:spcPct val="105000"/>
               </a:lnSpc>
@@ -5625,7 +5625,7 @@
                 <a:ea typeface="Calibri" pitchFamily="34" charset="-122"/>
                 <a:cs typeface="Calibri" pitchFamily="34" charset="-120"/>
               </a:rPr>
-              <a:t>Enxerga viagens, ocupação e faltas; extrai relatórios prontos.</a:t>
+              <a:t>Enxerga a agenda do dia, a ocupação e as faltas; extrai relatórios prontos.</a:t>
             </a:r>
             <a:endParaRPr lang="en-US" sz="1350" dirty="0"/>
           </a:p>
@@ -5639,12 +5639,12 @@
         </p:nvSpPr>
         <p:spPr>
           <a:xfrm>
-            <a:off x="822960" y="4160520"/>
-            <a:ext cx="5120640" cy="1874520"/>
+            <a:off x="8522208" y="2194560"/>
+            <a:ext cx="3511296" cy="3063240"/>
           </a:xfrm>
           <a:prstGeom prst="roundRect">
             <a:avLst>
-              <a:gd name="adj" fmla="val 4878"/>
+              <a:gd name="adj" fmla="val 3582"/>
             </a:avLst>
           </a:prstGeom>
           <a:solidFill>
@@ -5666,14 +5666,14 @@
         </p:nvSpPr>
         <p:spPr>
           <a:xfrm>
-            <a:off x="1143000" y="4617720"/>
-            <a:ext cx="960120" cy="960120"/>
+            <a:off x="9729216" y="2606040"/>
+            <a:ext cx="1097280" cy="1097280"/>
           </a:xfrm>
           <a:prstGeom prst="ellipse">
             <a:avLst/>
           </a:prstGeom>
           <a:solidFill>
-            <a:srgbClr val="037E8F"/>
+            <a:srgbClr val="16C79A"/>
           </a:solidFill>
           <a:ln/>
         </p:spPr>
@@ -5694,8 +5694,8 @@
         </p:blipFill>
         <p:spPr>
           <a:xfrm>
-            <a:off x="1389888" y="4864608"/>
-            <a:ext cx="466344" cy="466344"/>
+            <a:off x="10012680" y="2889504"/>
+            <a:ext cx="530352" cy="530352"/>
           </a:xfrm>
           <a:prstGeom prst="rect">
             <a:avLst/>
@@ -5710,8 +5710,8 @@
         </p:nvSpPr>
         <p:spPr>
           <a:xfrm>
-            <a:off x="2331720" y="4544568"/>
-            <a:ext cx="3337560" cy="457200"/>
+            <a:off x="8796528" y="3886200"/>
+            <a:ext cx="2962656" cy="457200"/>
           </a:xfrm>
           <a:prstGeom prst="rect">
             <a:avLst/>
@@ -5723,11 +5723,11 @@
           <a:bodyPr wrap="square" lIns="0" tIns="0" rIns="0" bIns="0" rtlCol="0" anchor="ctr"/>
           <a:lstStyle/>
           <a:p>
-            <a:pPr indent="0" marL="0">
-              <a:buNone/>
-            </a:pPr>
-            <a:r>
-              <a:rPr lang="en-US" sz="1800" b="1" dirty="0">
+            <a:pPr algn="ctr" indent="0" marL="0">
+              <a:buNone/>
+            </a:pPr>
+            <a:r>
+              <a:rPr lang="en-US" sz="1900" b="1" dirty="0">
                 <a:solidFill>
                   <a:srgbClr val="16323A"/>
                 </a:solidFill>
@@ -5735,9 +5735,9 @@
                 <a:ea typeface="Calibri" pitchFamily="34" charset="-122"/>
                 <a:cs typeface="Calibri" pitchFamily="34" charset="-120"/>
               </a:rPr>
-              <a:t>Motorista</a:t>
-            </a:r>
-            <a:endParaRPr lang="en-US" sz="1800" dirty="0"/>
+              <a:t>Paciente</a:t>
+            </a:r>
+            <a:endParaRPr lang="en-US" sz="1900" dirty="0"/>
           </a:p>
         </p:txBody>
       </p:sp>
@@ -5749,8 +5749,8 @@
         </p:nvSpPr>
         <p:spPr>
           <a:xfrm>
-            <a:off x="2331720" y="5001768"/>
-            <a:ext cx="3337560" cy="914400"/>
+            <a:off x="8887968" y="4389120"/>
+            <a:ext cx="2779776" cy="777240"/>
           </a:xfrm>
           <a:prstGeom prst="rect">
             <a:avLst/>
@@ -5762,159 +5762,7 @@
           <a:bodyPr wrap="square" lIns="0" tIns="0" rIns="0" bIns="0" rtlCol="0" anchor="t"/>
           <a:lstStyle/>
           <a:p>
-            <a:pPr indent="0" marL="0">
-              <a:lnSpc>
-                <a:spcPct val="105000"/>
-              </a:lnSpc>
-              <a:buNone/>
-            </a:pPr>
-            <a:r>
-              <a:rPr lang="en-US" sz="1350" dirty="0">
-                <a:solidFill>
-                  <a:srgbClr val="5C7178"/>
-                </a:solidFill>
-                <a:latin typeface="Calibri" pitchFamily="34" charset="0"/>
-                <a:ea typeface="Calibri" pitchFamily="34" charset="-122"/>
-                <a:cs typeface="Calibri" pitchFamily="34" charset="-120"/>
-              </a:rPr>
-              <a:t>Recebe o mapa da viagem com a lista completa de passageiros.</a:t>
-            </a:r>
-            <a:endParaRPr lang="en-US" sz="1350" dirty="0"/>
-          </a:p>
-        </p:txBody>
-      </p:sp>
-      <p:sp>
-        <p:nvSpPr>
-          <p:cNvPr id="20" name="Shape 15"/>
-          <p:cNvSpPr/>
-          <p:nvPr/>
-        </p:nvSpPr>
-        <p:spPr>
-          <a:xfrm>
-            <a:off x="6263640" y="4160520"/>
-            <a:ext cx="5120640" cy="1874520"/>
-          </a:xfrm>
-          <a:prstGeom prst="roundRect">
-            <a:avLst>
-              <a:gd name="adj" fmla="val 4878"/>
-            </a:avLst>
-          </a:prstGeom>
-          <a:solidFill>
-            <a:srgbClr val="E9F5F3"/>
-          </a:solidFill>
-          <a:ln w="12700">
-            <a:solidFill>
-              <a:srgbClr val="CFE3E0"/>
-            </a:solidFill>
-            <a:prstDash val="solid"/>
-          </a:ln>
-        </p:spPr>
-      </p:sp>
-      <p:sp>
-        <p:nvSpPr>
-          <p:cNvPr id="21" name="Shape 16"/>
-          <p:cNvSpPr/>
-          <p:nvPr/>
-        </p:nvSpPr>
-        <p:spPr>
-          <a:xfrm>
-            <a:off x="6583680" y="4617720"/>
-            <a:ext cx="960120" cy="960120"/>
-          </a:xfrm>
-          <a:prstGeom prst="ellipse">
-            <a:avLst/>
-          </a:prstGeom>
-          <a:solidFill>
-            <a:srgbClr val="00A78E"/>
-          </a:solidFill>
-          <a:ln/>
-        </p:spPr>
-      </p:sp>
-      <p:pic>
-        <p:nvPicPr>
-          <p:cNvPr id="22" name="Image 3" descr="preencoded.png">    </p:cNvPr>
-          <p:cNvPicPr>
-            <a:picLocks noChangeAspect="1"/>
-          </p:cNvPicPr>
-          <p:nvPr/>
-        </p:nvPicPr>
-        <p:blipFill>
-          <a:blip r:embed="rId4"/>
-          <a:stretch>
-            <a:fillRect/>
-          </a:stretch>
-        </p:blipFill>
-        <p:spPr>
-          <a:xfrm>
-            <a:off x="6830568" y="4864608"/>
-            <a:ext cx="466344" cy="466344"/>
-          </a:xfrm>
-          <a:prstGeom prst="rect">
-            <a:avLst/>
-          </a:prstGeom>
-        </p:spPr>
-      </p:pic>
-      <p:sp>
-        <p:nvSpPr>
-          <p:cNvPr id="23" name="Text 17"/>
-          <p:cNvSpPr/>
-          <p:nvPr/>
-        </p:nvSpPr>
-        <p:spPr>
-          <a:xfrm>
-            <a:off x="7772400" y="4544568"/>
-            <a:ext cx="3337560" cy="457200"/>
-          </a:xfrm>
-          <a:prstGeom prst="rect">
-            <a:avLst/>
-          </a:prstGeom>
-          <a:noFill/>
-          <a:ln/>
-        </p:spPr>
-        <p:txBody>
-          <a:bodyPr wrap="square" lIns="0" tIns="0" rIns="0" bIns="0" rtlCol="0" anchor="ctr"/>
-          <a:lstStyle/>
-          <a:p>
-            <a:pPr indent="0" marL="0">
-              <a:buNone/>
-            </a:pPr>
-            <a:r>
-              <a:rPr lang="en-US" sz="1800" b="1" dirty="0">
-                <a:solidFill>
-                  <a:srgbClr val="16323A"/>
-                </a:solidFill>
-                <a:latin typeface="Calibri" pitchFamily="34" charset="0"/>
-                <a:ea typeface="Calibri" pitchFamily="34" charset="-122"/>
-                <a:cs typeface="Calibri" pitchFamily="34" charset="-120"/>
-              </a:rPr>
-              <a:t>Paciente</a:t>
-            </a:r>
-            <a:endParaRPr lang="en-US" sz="1800" dirty="0"/>
-          </a:p>
-        </p:txBody>
-      </p:sp>
-      <p:sp>
-        <p:nvSpPr>
-          <p:cNvPr id="24" name="Text 18"/>
-          <p:cNvSpPr/>
-          <p:nvPr/>
-        </p:nvSpPr>
-        <p:spPr>
-          <a:xfrm>
-            <a:off x="7772400" y="5001768"/>
-            <a:ext cx="3337560" cy="914400"/>
-          </a:xfrm>
-          <a:prstGeom prst="rect">
-            <a:avLst/>
-          </a:prstGeom>
-          <a:noFill/>
-          <a:ln/>
-        </p:spPr>
-        <p:txBody>
-          <a:bodyPr wrap="square" lIns="0" tIns="0" rIns="0" bIns="0" rtlCol="0" anchor="t"/>
-          <a:lstStyle/>
-          <a:p>
-            <a:pPr indent="0" marL="0">
+            <a:pPr algn="ctr" indent="0" marL="0">
               <a:lnSpc>
                 <a:spcPct val="105000"/>
               </a:lnSpc>
@@ -6279,7 +6127,7 @@
                 <a:ea typeface="Calibri" pitchFamily="34" charset="-122"/>
                 <a:cs typeface="Calibri" pitchFamily="34" charset="-120"/>
               </a:rPr>
-              <a:t>Veículos e lotação</a:t>
+              <a:t>Agenda de horários</a:t>
             </a:r>
             <a:endParaRPr lang="en-US" sz="1400" dirty="0"/>
           </a:p>
@@ -6389,7 +6237,7 @@
                 <a:ea typeface="Calibri" pitchFamily="34" charset="-122"/>
                 <a:cs typeface="Calibri" pitchFamily="34" charset="-120"/>
               </a:rPr>
-              <a:t>Motoristas e viagens</a:t>
+              <a:t>Agendamento</a:t>
             </a:r>
             <a:endParaRPr lang="en-US" sz="1400" dirty="0"/>
           </a:p>
@@ -6499,7 +6347,7 @@
                 <a:ea typeface="Calibri" pitchFamily="34" charset="-122"/>
                 <a:cs typeface="Calibri" pitchFamily="34" charset="-120"/>
               </a:rPr>
-              <a:t>Mapa de viagem</a:t>
+              <a:t>Lista do dia</a:t>
             </a:r>
             <a:endParaRPr lang="en-US" sz="1400" dirty="0"/>
           </a:p>
@@ -8053,7 +7901,7 @@
                 <a:ea typeface="Calibri" pitchFamily="34" charset="-122"/>
                 <a:cs typeface="Calibri" pitchFamily="34" charset="-120"/>
               </a:rPr>
-              <a:t>Pacientes, veículos, motoristas e acessos</a:t>
+              <a:t>Pacientes, destinos e acessos</a:t>
             </a:r>
             <a:endParaRPr lang="en-US" sz="1150" dirty="0"/>
           </a:p>
@@ -8198,7 +8046,7 @@
                 <a:ea typeface="Calibri" pitchFamily="34" charset="-122"/>
                 <a:cs typeface="Calibri" pitchFamily="34" charset="-120"/>
               </a:rPr>
-              <a:t>Agendamento, cartão de embarque e mapa da viagem</a:t>
+              <a:t>Agenda por horário, cartão e lista do dia</a:t>
             </a:r>
             <a:endParaRPr lang="en-US" sz="1150" dirty="0"/>
           </a:p>

</xml_diff>